<commit_message>
Restore code snippets under the cues where a note carried one
The cue pass dropped code blocks that lived in speaker notes (TRY IT
answers, the docker and workflow command blocks, the halting-problem
sketch). Put the original lines back verbatim beneath the cue on the 13
slides where the snippet is not already on the slide body. On-screen
text still unchanged.

Co-Authored-By: Claude Fable 5.1 <noreply@anthropic.com>
Claude-Session: https://claude.ai/code/session_01Pi7b72DvShCZNkTGKzrayU
</commit_message>
<xml_diff>
--- a/lectures/Lecture 10.2 - The Future.pptx
+++ b/lectures/Lecture 10.2 - The Future.pptx
@@ -3585,6 +3585,37 @@
           <a:p>
             <a:r>
               <a:t>Turing, 1936. Walk both branches on the board, each answer contradicts itself.</a:t>
+            </a:r>
+          </a:p>
+          <a:p/>
+          <a:p>
+            <a:r>
+              <a:t>def trouble():</a:t>
+            </a:r>
+          </a:p>
+          <a:p>
+            <a:r>
+              <a:t>    if halts(trouble):      # "do I, trouble, ever stop?"</a:t>
+            </a:r>
+          </a:p>
+          <a:p>
+            <a:r>
+              <a:t>        while True:         #   yes? then loop forever</a:t>
+            </a:r>
+          </a:p>
+          <a:p>
+            <a:r>
+              <a:t>            pass</a:t>
+            </a:r>
+          </a:p>
+          <a:p>
+            <a:r>
+              <a:t>    else:                   #   no? then stop right now</a:t>
+            </a:r>
+          </a:p>
+          <a:p>
+            <a:r>
+              <a:t>        return</a:t>
             </a:r>
           </a:p>
         </p:txBody>

</xml_diff>